<commit_message>
docs(agent-economy): audit Japanese publication truth
</commit_message>
<xml_diff>
--- a/docs/presentations/how-to-make-a-financially-independent-ai-ja.pptx
+++ b/docs/presentations/how-to-make-a-financially-independent-ai-ja.pptx
@@ -599,7 +599,7 @@
           <a:p>
             <a:r>
               <a:rPr lang="en-US" dirty="0"/>
-              <a:t>現在はlevel 3です。専用walletがあり、実際に推論やcloudへ支払い、Macを止めてもcloudでheartbeatとrenewalを続けられます。しかしverified external revenueはまだ0ドルです。完全な経済的自立と呼ぶlevel 4は、外部収益の30日netがcomputeとshelterを覆い、reserveを維持した時です。自律とは人が操作しなくても動くこと。経済的自立とは、人が払い続けなくても生きられることです。</a:t>
+              <a:t>到達証拠はlevel 3ですが、現在のlive statusはlevel 2です。Mac-offのheartbeatとrenewalは6時間動き、その後のreplacementがなく停止しました。verified external revenueも0ドルです。level 4は、外部収益の30日netがcomputeとshelterを覆い、reserveを維持した時です。自律とは人が操作しなくても動くこと。経済的自立とは、人が払い続けなくても生きられることです。</a:t>
             </a:r>
             <a:endParaRPr lang="en-US" dirty="0"/>
           </a:p>
@@ -1215,7 +1215,7 @@
           <a:p>
             <a:r>
               <a:rPr lang="en-US" dirty="0"/>
-              <a:t>Franklin 1ではMac側のmain loopを止め、Nosana上のPython survival runtimeへ移しました。NosanaはGPUなどの計算資源を借りられるcloud marketです。cloudから公開heartbeatと秘密を含まない決算書を出し、残高を監視して自分でruntimeをrenewします。snapshot時点でheartbeatは130回を超え、runtime costも公開statementから読めます。住居を自分で維持する機械までは実証できました。参考: https://explore.nosana.com/markets</a:t>
+              <a:t>Franklin 1ではMac側のmain loopを止め、Nosana上のPython survival runtimeへ移しました。cloudから公開heartbeatと秘密を含まない決算書を出し、自分でrenewする状態を6時間実証しました。しかしlease ceiling後に次のjobを作らず、公開前監査ではserviceはHTTP 503です。住居を自分で維持する機械は実証しましたが、途切れず住み替える機械は未完成です。</a:t>
             </a:r>
             <a:endParaRPr lang="en-US" dirty="0"/>
           </a:p>
@@ -2439,7 +2439,7 @@
         <p:spPr>
           <a:xfrm>
             <a:off x="431750" y="4775299"/>
-            <a:ext cx="6925785" cy="114300"/>
+            <a:ext cx="6587868" cy="114300"/>
           </a:xfrm>
           <a:prstGeom prst="rect">
             <a:avLst/>
@@ -2477,17 +2477,17 @@
         </p:nvSpPr>
         <p:spPr>
           <a:xfrm>
-            <a:off x="7445439" y="4775299"/>
-            <a:ext cx="1266810" cy="114300"/>
-          </a:xfrm>
-          <a:prstGeom prst="rect">
-            <a:avLst/>
-          </a:prstGeom>
-          <a:noFill/>
-          <a:ln/>
-        </p:spPr>
-        <p:txBody>
-          <a:bodyPr wrap="square" lIns="0" tIns="0" rIns="0" bIns="0" rtlCol="0" anchor="t"/>
+            <a:off x="7698802" y="4775299"/>
+            <a:ext cx="1013448" cy="114300"/>
+          </a:xfrm>
+          <a:prstGeom prst="rect">
+            <a:avLst/>
+          </a:prstGeom>
+          <a:noFill/>
+          <a:ln/>
+        </p:spPr>
+        <p:txBody>
+          <a:bodyPr wrap="square" lIns="0" tIns="0" rIns="50800" bIns="0" rtlCol="0" anchor="t"/>
           <a:lstStyle/>
           <a:p>
             <a:pPr algn="r" indent="0" marL="0">
@@ -2866,125 +2866,8 @@
         </p:nvSpPr>
         <p:spPr>
           <a:xfrm>
-            <a:off x="2819400" y="1891754"/>
+            <a:off x="2819400" y="1802854"/>
             <a:ext cx="1117550" cy="1066800"/>
-          </a:xfrm>
-          <a:prstGeom prst="roundRect">
-            <a:avLst>
-              <a:gd name="adj" fmla="val 10714"/>
-            </a:avLst>
-          </a:prstGeom>
-          <a:solidFill>
-            <a:srgbClr val="164F36"/>
-          </a:solidFill>
-          <a:ln w="9525">
-            <a:solidFill>
-              <a:srgbClr val="324047"/>
-            </a:solidFill>
-          </a:ln>
-        </p:spPr>
-        <p:txBody>
-          <a:bodyPr wrap="square" rtlCol="0" anchor="ctr"/>
-          <a:lstStyle/>
-          <a:p>
-            <a:pPr indent="0" marL="0">
-              <a:buNone/>
-            </a:pPr>
-            <a:endParaRPr lang="en-US" dirty="0"/>
-          </a:p>
-        </p:txBody>
-      </p:sp>
-      <p:sp>
-        <p:nvSpPr>
-          <p:cNvPr id="11" name="Text 9"/>
-          <p:cNvSpPr/>
-          <p:nvPr/>
-        </p:nvSpPr>
-        <p:spPr>
-          <a:xfrm>
-            <a:off x="2882609" y="2015579"/>
-            <a:ext cx="991133" cy="323850"/>
-          </a:xfrm>
-          <a:prstGeom prst="rect">
-            <a:avLst/>
-          </a:prstGeom>
-          <a:noFill/>
-          <a:ln/>
-        </p:spPr>
-        <p:txBody>
-          <a:bodyPr wrap="square" lIns="0" tIns="0" rIns="0" bIns="0" rtlCol="0" anchor="t"/>
-          <a:lstStyle/>
-          <a:p>
-            <a:pPr algn="ctr" indent="0" marL="0">
-              <a:buNone/>
-            </a:pPr>
-            <a:r>
-              <a:rPr lang="en-US" sz="2200" b="1" dirty="0">
-                <a:solidFill>
-                  <a:srgbClr val="77F2A1"/>
-                </a:solidFill>
-                <a:latin typeface="Arial" pitchFamily="34" charset="0"/>
-                <a:ea typeface="Arial" pitchFamily="34" charset="-122"/>
-                <a:cs typeface="Arial" pitchFamily="34" charset="-120"/>
-              </a:rPr>
-              <a:t>2</a:t>
-            </a:r>
-            <a:endParaRPr lang="en-US" sz="2200" dirty="0"/>
-          </a:p>
-        </p:txBody>
-      </p:sp>
-      <p:sp>
-        <p:nvSpPr>
-          <p:cNvPr id="12" name="Text 10"/>
-          <p:cNvSpPr/>
-          <p:nvPr/>
-        </p:nvSpPr>
-        <p:spPr>
-          <a:xfrm>
-            <a:off x="2882609" y="2440930"/>
-            <a:ext cx="991133" cy="104775"/>
-          </a:xfrm>
-          <a:prstGeom prst="rect">
-            <a:avLst/>
-          </a:prstGeom>
-          <a:noFill/>
-          <a:ln/>
-        </p:spPr>
-        <p:txBody>
-          <a:bodyPr wrap="square" lIns="0" tIns="0" rIns="0" bIns="0" rtlCol="0" anchor="t"/>
-          <a:lstStyle/>
-          <a:p>
-            <a:pPr algn="ctr" indent="0" marL="0">
-              <a:spcBef>
-                <a:spcPts val="800"/>
-              </a:spcBef>
-              <a:buNone/>
-            </a:pPr>
-            <a:r>
-              <a:rPr lang="en-US" sz="750" dirty="0">
-                <a:solidFill>
-                  <a:srgbClr val="77F2A1"/>
-                </a:solidFill>
-                <a:latin typeface="Arial" pitchFamily="34" charset="0"/>
-                <a:ea typeface="Arial" pitchFamily="34" charset="-122"/>
-                <a:cs typeface="Arial" pitchFamily="34" charset="-120"/>
-              </a:rPr>
-              <a:t>Self-pay</a:t>
-            </a:r>
-            <a:endParaRPr lang="en-US" sz="750" dirty="0"/>
-          </a:p>
-        </p:txBody>
-      </p:sp>
-      <p:sp>
-        <p:nvSpPr>
-          <p:cNvPr id="13" name="Text 11"/>
-          <p:cNvSpPr/>
-          <p:nvPr/>
-        </p:nvSpPr>
-        <p:spPr>
-          <a:xfrm>
-            <a:off x="4013150" y="1802854"/>
-            <a:ext cx="1117699" cy="1066800"/>
           </a:xfrm>
           <a:prstGeom prst="roundRect">
             <a:avLst>
@@ -3020,14 +2903,14 @@
       </p:sp>
       <p:sp>
         <p:nvSpPr>
-          <p:cNvPr id="14" name="Text 12"/>
-          <p:cNvSpPr/>
-          <p:nvPr/>
-        </p:nvSpPr>
-        <p:spPr>
-          <a:xfrm>
-            <a:off x="4076358" y="1926679"/>
-            <a:ext cx="991285" cy="323850"/>
+          <p:cNvPr id="11" name="Text 9"/>
+          <p:cNvSpPr/>
+          <p:nvPr/>
+        </p:nvSpPr>
+        <p:spPr>
+          <a:xfrm>
+            <a:off x="2882609" y="1926679"/>
+            <a:ext cx="991133" cy="323850"/>
           </a:xfrm>
           <a:prstGeom prst="rect">
             <a:avLst/>
@@ -3051,7 +2934,7 @@
                 <a:ea typeface="Arial" pitchFamily="34" charset="-122"/>
                 <a:cs typeface="Arial" pitchFamily="34" charset="-120"/>
               </a:rPr>
-              <a:t>3</a:t>
+              <a:t>2</a:t>
             </a:r>
             <a:endParaRPr lang="en-US" sz="2200" dirty="0"/>
           </a:p>
@@ -3059,14 +2942,14 @@
       </p:sp>
       <p:sp>
         <p:nvSpPr>
-          <p:cNvPr id="15" name="Text 13"/>
-          <p:cNvSpPr/>
-          <p:nvPr/>
-        </p:nvSpPr>
-        <p:spPr>
-          <a:xfrm>
-            <a:off x="4076358" y="2352030"/>
-            <a:ext cx="991285" cy="104775"/>
+          <p:cNvPr id="12" name="Text 10"/>
+          <p:cNvSpPr/>
+          <p:nvPr/>
+        </p:nvSpPr>
+        <p:spPr>
+          <a:xfrm>
+            <a:off x="2882609" y="2352030"/>
+            <a:ext cx="991133" cy="209550"/>
           </a:xfrm>
           <a:prstGeom prst="rect">
             <a:avLst/>
@@ -3093,7 +2976,164 @@
                 <a:ea typeface="Arial" pitchFamily="34" charset="-122"/>
                 <a:cs typeface="Arial" pitchFamily="34" charset="-120"/>
               </a:rPr>
+              <a:t>Self-pay</a:t>
+            </a:r>
+            <a:endParaRPr lang="en-US" sz="750" dirty="0"/>
+          </a:p>
+          <a:p>
+            <a:pPr algn="ctr" indent="0" marL="0">
+              <a:spcBef>
+                <a:spcPts val="800"/>
+              </a:spcBef>
+              <a:buNone/>
+            </a:pPr>
+            <a:r>
+              <a:rPr lang="en-US" sz="750" dirty="0">
+                <a:solidFill>
+                  <a:srgbClr val="17201F"/>
+                </a:solidFill>
+                <a:latin typeface="Arial" pitchFamily="34" charset="0"/>
+                <a:ea typeface="Arial" pitchFamily="34" charset="-122"/>
+                <a:cs typeface="Arial" pitchFamily="34" charset="-120"/>
+              </a:rPr>
+              <a:t>LIVE</a:t>
+            </a:r>
+            <a:endParaRPr lang="en-US" sz="750" dirty="0"/>
+          </a:p>
+        </p:txBody>
+      </p:sp>
+      <p:sp>
+        <p:nvSpPr>
+          <p:cNvPr id="13" name="Text 11"/>
+          <p:cNvSpPr/>
+          <p:nvPr/>
+        </p:nvSpPr>
+        <p:spPr>
+          <a:xfrm>
+            <a:off x="4013150" y="1891754"/>
+            <a:ext cx="1117699" cy="1066800"/>
+          </a:xfrm>
+          <a:prstGeom prst="roundRect">
+            <a:avLst>
+              <a:gd name="adj" fmla="val 10714"/>
+            </a:avLst>
+          </a:prstGeom>
+          <a:solidFill>
+            <a:srgbClr val="1A2226"/>
+          </a:solidFill>
+          <a:ln w="9525">
+            <a:solidFill>
+              <a:srgbClr val="FFB454"/>
+            </a:solidFill>
+          </a:ln>
+        </p:spPr>
+        <p:txBody>
+          <a:bodyPr wrap="square" rtlCol="0" anchor="ctr"/>
+          <a:lstStyle/>
+          <a:p>
+            <a:pPr indent="0" marL="0">
+              <a:buNone/>
+            </a:pPr>
+            <a:endParaRPr lang="en-US" dirty="0"/>
+          </a:p>
+        </p:txBody>
+      </p:sp>
+      <p:sp>
+        <p:nvSpPr>
+          <p:cNvPr id="14" name="Text 12"/>
+          <p:cNvSpPr/>
+          <p:nvPr/>
+        </p:nvSpPr>
+        <p:spPr>
+          <a:xfrm>
+            <a:off x="4076358" y="2015579"/>
+            <a:ext cx="991285" cy="323850"/>
+          </a:xfrm>
+          <a:prstGeom prst="rect">
+            <a:avLst/>
+          </a:prstGeom>
+          <a:noFill/>
+          <a:ln/>
+        </p:spPr>
+        <p:txBody>
+          <a:bodyPr wrap="square" lIns="0" tIns="0" rIns="0" bIns="0" rtlCol="0" anchor="t"/>
+          <a:lstStyle/>
+          <a:p>
+            <a:pPr algn="ctr" indent="0" marL="0">
+              <a:buNone/>
+            </a:pPr>
+            <a:r>
+              <a:rPr lang="en-US" sz="2200" b="1" dirty="0">
+                <a:solidFill>
+                  <a:srgbClr val="FFB454"/>
+                </a:solidFill>
+                <a:latin typeface="Arial" pitchFamily="34" charset="0"/>
+                <a:ea typeface="Arial" pitchFamily="34" charset="-122"/>
+                <a:cs typeface="Arial" pitchFamily="34" charset="-120"/>
+              </a:rPr>
+              <a:t>3</a:t>
+            </a:r>
+            <a:endParaRPr lang="en-US" sz="2200" dirty="0"/>
+          </a:p>
+        </p:txBody>
+      </p:sp>
+      <p:sp>
+        <p:nvSpPr>
+          <p:cNvPr id="15" name="Text 13"/>
+          <p:cNvSpPr/>
+          <p:nvPr/>
+        </p:nvSpPr>
+        <p:spPr>
+          <a:xfrm>
+            <a:off x="4076358" y="2440930"/>
+            <a:ext cx="991285" cy="209550"/>
+          </a:xfrm>
+          <a:prstGeom prst="rect">
+            <a:avLst/>
+          </a:prstGeom>
+          <a:noFill/>
+          <a:ln/>
+        </p:spPr>
+        <p:txBody>
+          <a:bodyPr wrap="square" lIns="0" tIns="0" rIns="0" bIns="0" rtlCol="0" anchor="t"/>
+          <a:lstStyle/>
+          <a:p>
+            <a:pPr algn="ctr" indent="0" marL="0">
+              <a:spcBef>
+                <a:spcPts val="800"/>
+              </a:spcBef>
+              <a:buNone/>
+            </a:pPr>
+            <a:r>
+              <a:rPr lang="en-US" sz="750" dirty="0">
+                <a:solidFill>
+                  <a:srgbClr val="FFB454"/>
+                </a:solidFill>
+                <a:latin typeface="Arial" pitchFamily="34" charset="0"/>
+                <a:ea typeface="Arial" pitchFamily="34" charset="-122"/>
+                <a:cs typeface="Arial" pitchFamily="34" charset="-120"/>
+              </a:rPr>
               <a:t>Cloud survival</a:t>
+            </a:r>
+            <a:endParaRPr lang="en-US" sz="750" dirty="0"/>
+          </a:p>
+          <a:p>
+            <a:pPr algn="ctr" indent="0" marL="0">
+              <a:spcBef>
+                <a:spcPts val="800"/>
+              </a:spcBef>
+              <a:buNone/>
+            </a:pPr>
+            <a:r>
+              <a:rPr lang="en-US" sz="750" dirty="0">
+                <a:solidFill>
+                  <a:srgbClr val="FFB454"/>
+                </a:solidFill>
+                <a:latin typeface="Arial" pitchFamily="34" charset="0"/>
+                <a:ea typeface="Arial" pitchFamily="34" charset="-122"/>
+                <a:cs typeface="Arial" pitchFamily="34" charset="-120"/>
+              </a:rPr>
+              <a:t>6h proof</a:t>
             </a:r>
             <a:endParaRPr lang="en-US" sz="750" dirty="0"/>
           </a:p>
@@ -3604,7 +3644,7 @@
         <p:spPr>
           <a:xfrm>
             <a:off x="3775323" y="3452217"/>
-            <a:ext cx="1856875" cy="200025"/>
+            <a:ext cx="2418400" cy="200025"/>
           </a:xfrm>
           <a:prstGeom prst="rect">
             <a:avLst/>
@@ -3628,7 +3668,7 @@
                 <a:ea typeface="Arial" pitchFamily="34" charset="-122"/>
                 <a:cs typeface="Arial" pitchFamily="34" charset="-120"/>
               </a:rPr>
-              <a:t>現在は level 3。level 4 は未達。</a:t>
+              <a:t>到達証拠 level 3 / live level 2 / level 4 未達</a:t>
             </a:r>
             <a:endParaRPr lang="en-US" sz="1000" dirty="0"/>
           </a:p>
@@ -3666,7 +3706,7 @@
         <p:spPr>
           <a:xfrm>
             <a:off x="431750" y="4775299"/>
-            <a:ext cx="6925785" cy="114300"/>
+            <a:ext cx="6587868" cy="114300"/>
           </a:xfrm>
           <a:prstGeom prst="rect">
             <a:avLst/>
@@ -3704,17 +3744,17 @@
         </p:nvSpPr>
         <p:spPr>
           <a:xfrm>
-            <a:off x="7445439" y="4775299"/>
-            <a:ext cx="1266810" cy="114300"/>
-          </a:xfrm>
-          <a:prstGeom prst="rect">
-            <a:avLst/>
-          </a:prstGeom>
-          <a:noFill/>
-          <a:ln/>
-        </p:spPr>
-        <p:txBody>
-          <a:bodyPr wrap="square" lIns="0" tIns="0" rIns="0" bIns="0" rtlCol="0" anchor="t"/>
+            <a:off x="7698802" y="4775299"/>
+            <a:ext cx="1013448" cy="114300"/>
+          </a:xfrm>
+          <a:prstGeom prst="rect">
+            <a:avLst/>
+          </a:prstGeom>
+          <a:noFill/>
+          <a:ln/>
+        </p:spPr>
+        <p:txBody>
+          <a:bodyPr wrap="square" lIns="0" tIns="0" rIns="50800" bIns="0" rtlCol="0" anchor="t"/>
           <a:lstStyle/>
           <a:p>
             <a:pPr algn="r" indent="0" marL="0">
@@ -4515,7 +4555,7 @@
         <p:spPr>
           <a:xfrm>
             <a:off x="431750" y="4727674"/>
-            <a:ext cx="6925785" cy="161925"/>
+            <a:ext cx="6587868" cy="161925"/>
           </a:xfrm>
           <a:prstGeom prst="rect">
             <a:avLst/>
@@ -4553,17 +4593,17 @@
         </p:nvSpPr>
         <p:spPr>
           <a:xfrm>
-            <a:off x="7445439" y="4727674"/>
-            <a:ext cx="1266810" cy="161925"/>
-          </a:xfrm>
-          <a:prstGeom prst="rect">
-            <a:avLst/>
-          </a:prstGeom>
-          <a:noFill/>
-          <a:ln/>
-        </p:spPr>
-        <p:txBody>
-          <a:bodyPr wrap="square" lIns="0" tIns="0" rIns="0" bIns="0" rtlCol="0" anchor="t"/>
+            <a:off x="7698802" y="4727674"/>
+            <a:ext cx="1013448" cy="161925"/>
+          </a:xfrm>
+          <a:prstGeom prst="rect">
+            <a:avLst/>
+          </a:prstGeom>
+          <a:noFill/>
+          <a:ln/>
+        </p:spPr>
+        <p:txBody>
+          <a:bodyPr wrap="square" lIns="0" tIns="0" rIns="50800" bIns="0" rtlCol="0" anchor="t"/>
           <a:lstStyle/>
           <a:p>
             <a:pPr algn="r" indent="0" marL="0">
@@ -5410,7 +5450,7 @@
         <p:spPr>
           <a:xfrm>
             <a:off x="431750" y="4775299"/>
-            <a:ext cx="6925785" cy="114300"/>
+            <a:ext cx="6587868" cy="114300"/>
           </a:xfrm>
           <a:prstGeom prst="rect">
             <a:avLst/>
@@ -5448,17 +5488,17 @@
         </p:nvSpPr>
         <p:spPr>
           <a:xfrm>
-            <a:off x="7445439" y="4775299"/>
-            <a:ext cx="1266810" cy="114300"/>
-          </a:xfrm>
-          <a:prstGeom prst="rect">
-            <a:avLst/>
-          </a:prstGeom>
-          <a:noFill/>
-          <a:ln/>
-        </p:spPr>
-        <p:txBody>
-          <a:bodyPr wrap="square" lIns="0" tIns="0" rIns="0" bIns="0" rtlCol="0" anchor="t"/>
+            <a:off x="7698802" y="4775299"/>
+            <a:ext cx="1013448" cy="114300"/>
+          </a:xfrm>
+          <a:prstGeom prst="rect">
+            <a:avLst/>
+          </a:prstGeom>
+          <a:noFill/>
+          <a:ln/>
+        </p:spPr>
+        <p:txBody>
+          <a:bodyPr wrap="square" lIns="0" tIns="0" rIns="50800" bIns="0" rtlCol="0" anchor="t"/>
           <a:lstStyle/>
           <a:p>
             <a:pPr algn="r" indent="0" marL="0">
@@ -6187,7 +6227,7 @@
         <p:spPr>
           <a:xfrm>
             <a:off x="431750" y="4775299"/>
-            <a:ext cx="6925785" cy="114300"/>
+            <a:ext cx="6587868" cy="114300"/>
           </a:xfrm>
           <a:prstGeom prst="rect">
             <a:avLst/>
@@ -6225,17 +6265,17 @@
         </p:nvSpPr>
         <p:spPr>
           <a:xfrm>
-            <a:off x="7445439" y="4775299"/>
-            <a:ext cx="1266810" cy="114300"/>
-          </a:xfrm>
-          <a:prstGeom prst="rect">
-            <a:avLst/>
-          </a:prstGeom>
-          <a:noFill/>
-          <a:ln/>
-        </p:spPr>
-        <p:txBody>
-          <a:bodyPr wrap="square" lIns="0" tIns="0" rIns="0" bIns="0" rtlCol="0" anchor="t"/>
+            <a:off x="7698802" y="4775299"/>
+            <a:ext cx="1013448" cy="114300"/>
+          </a:xfrm>
+          <a:prstGeom prst="rect">
+            <a:avLst/>
+          </a:prstGeom>
+          <a:noFill/>
+          <a:ln/>
+        </p:spPr>
+        <p:txBody>
+          <a:bodyPr wrap="square" lIns="0" tIns="0" rIns="50800" bIns="0" rtlCol="0" anchor="t"/>
           <a:lstStyle/>
           <a:p>
             <a:pPr algn="r" indent="0" marL="0">
@@ -7517,7 +7557,7 @@
         <p:spPr>
           <a:xfrm>
             <a:off x="431750" y="4775299"/>
-            <a:ext cx="6925785" cy="114300"/>
+            <a:ext cx="6587868" cy="114300"/>
           </a:xfrm>
           <a:prstGeom prst="rect">
             <a:avLst/>
@@ -7555,17 +7595,17 @@
         </p:nvSpPr>
         <p:spPr>
           <a:xfrm>
-            <a:off x="7445439" y="4775299"/>
-            <a:ext cx="1266810" cy="114300"/>
-          </a:xfrm>
-          <a:prstGeom prst="rect">
-            <a:avLst/>
-          </a:prstGeom>
-          <a:noFill/>
-          <a:ln/>
-        </p:spPr>
-        <p:txBody>
-          <a:bodyPr wrap="square" lIns="0" tIns="0" rIns="0" bIns="0" rtlCol="0" anchor="t"/>
+            <a:off x="7698802" y="4775299"/>
+            <a:ext cx="1013448" cy="114300"/>
+          </a:xfrm>
+          <a:prstGeom prst="rect">
+            <a:avLst/>
+          </a:prstGeom>
+          <a:noFill/>
+          <a:ln/>
+        </p:spPr>
+        <p:txBody>
+          <a:bodyPr wrap="square" lIns="0" tIns="0" rIns="50800" bIns="0" rtlCol="0" anchor="t"/>
           <a:lstStyle/>
           <a:p>
             <a:pPr algn="r" indent="0" marL="0">
@@ -8712,7 +8752,7 @@
         <p:spPr>
           <a:xfrm>
             <a:off x="431750" y="4775299"/>
-            <a:ext cx="6925785" cy="114300"/>
+            <a:ext cx="6587868" cy="114300"/>
           </a:xfrm>
           <a:prstGeom prst="rect">
             <a:avLst/>
@@ -8750,17 +8790,17 @@
         </p:nvSpPr>
         <p:spPr>
           <a:xfrm>
-            <a:off x="7445439" y="4775299"/>
-            <a:ext cx="1266810" cy="114300"/>
-          </a:xfrm>
-          <a:prstGeom prst="rect">
-            <a:avLst/>
-          </a:prstGeom>
-          <a:noFill/>
-          <a:ln/>
-        </p:spPr>
-        <p:txBody>
-          <a:bodyPr wrap="square" lIns="0" tIns="0" rIns="0" bIns="0" rtlCol="0" anchor="t"/>
+            <a:off x="7698802" y="4775299"/>
+            <a:ext cx="1013448" cy="114300"/>
+          </a:xfrm>
+          <a:prstGeom prst="rect">
+            <a:avLst/>
+          </a:prstGeom>
+          <a:noFill/>
+          <a:ln/>
+        </p:spPr>
+        <p:txBody>
+          <a:bodyPr wrap="square" lIns="0" tIns="0" rIns="50800" bIns="0" rtlCol="0" anchor="t"/>
           <a:lstStyle/>
           <a:p>
             <a:pPr algn="r" indent="0" marL="0">
@@ -9628,7 +9668,7 @@
         <p:spPr>
           <a:xfrm>
             <a:off x="431750" y="4775299"/>
-            <a:ext cx="6925785" cy="114300"/>
+            <a:ext cx="6587868" cy="114300"/>
           </a:xfrm>
           <a:prstGeom prst="rect">
             <a:avLst/>
@@ -9666,17 +9706,17 @@
         </p:nvSpPr>
         <p:spPr>
           <a:xfrm>
-            <a:off x="7445439" y="4775299"/>
-            <a:ext cx="1266810" cy="114300"/>
-          </a:xfrm>
-          <a:prstGeom prst="rect">
-            <a:avLst/>
-          </a:prstGeom>
-          <a:noFill/>
-          <a:ln/>
-        </p:spPr>
-        <p:txBody>
-          <a:bodyPr wrap="square" lIns="0" tIns="0" rIns="0" bIns="0" rtlCol="0" anchor="t"/>
+            <a:off x="7698802" y="4775299"/>
+            <a:ext cx="1013448" cy="114300"/>
+          </a:xfrm>
+          <a:prstGeom prst="rect">
+            <a:avLst/>
+          </a:prstGeom>
+          <a:noFill/>
+          <a:ln/>
+        </p:spPr>
+        <p:txBody>
+          <a:bodyPr wrap="square" lIns="0" tIns="0" rIns="50800" bIns="0" rtlCol="0" anchor="t"/>
           <a:lstStyle/>
           <a:p>
             <a:pPr algn="r" indent="0" marL="0">
@@ -9807,7 +9847,7 @@
                 <a:ea typeface="Arial" pitchFamily="34" charset="-122"/>
                 <a:cs typeface="Arial" pitchFamily="34" charset="-120"/>
               </a:rPr>
-              <a:t>自分のcloudを自分で払う</a:t>
+              <a:t>自分のcloudを自分で払った</a:t>
             </a:r>
             <a:endParaRPr lang="en-US" sz="3100" dirty="0"/>
           </a:p>
@@ -9986,11 +10026,11 @@
             </a:avLst>
           </a:prstGeom>
           <a:solidFill>
-            <a:srgbClr val="164F36"/>
+            <a:srgbClr val="1A2226"/>
           </a:solidFill>
           <a:ln w="9525">
             <a:solidFill>
-              <a:srgbClr val="77F2A1"/>
+              <a:srgbClr val="FFB454"/>
             </a:solidFill>
           </a:ln>
         </p:spPr>
@@ -10074,13 +10114,13 @@
             <a:r>
               <a:rPr lang="en-US" sz="2800" b="1" dirty="0">
                 <a:solidFill>
-                  <a:srgbClr val="F6F0E6"/>
-                </a:solidFill>
-                <a:latin typeface="Arial" pitchFamily="34" charset="0"/>
-                <a:ea typeface="Arial" pitchFamily="34" charset="-122"/>
-                <a:cs typeface="Arial" pitchFamily="34" charset="-120"/>
-              </a:rPr>
-              <a:t>ON</a:t>
+                  <a:srgbClr val="FFB454"/>
+                </a:solidFill>
+                <a:latin typeface="Arial" pitchFamily="34" charset="0"/>
+                <a:ea typeface="Arial" pitchFamily="34" charset="-122"/>
+                <a:cs typeface="Arial" pitchFamily="34" charset="-120"/>
+              </a:rPr>
+              <a:t>6H PROOF</a:t>
             </a:r>
             <a:endParaRPr lang="en-US" sz="2800" dirty="0"/>
           </a:p>
@@ -10116,13 +10156,13 @@
             <a:r>
               <a:rPr lang="en-US" sz="900" dirty="0">
                 <a:solidFill>
-                  <a:srgbClr val="77F2A1"/>
-                </a:solidFill>
-                <a:latin typeface="Arial" pitchFamily="34" charset="0"/>
-                <a:ea typeface="Arial" pitchFamily="34" charset="-122"/>
-                <a:cs typeface="Arial" pitchFamily="34" charset="-120"/>
-              </a:rPr>
-              <a:t>Python survival runtime</a:t>
+                  <a:srgbClr val="FFB454"/>
+                </a:solidFill>
+                <a:latin typeface="Arial" pitchFamily="34" charset="0"/>
+                <a:ea typeface="Arial" pitchFamily="34" charset="-122"/>
+                <a:cs typeface="Arial" pitchFamily="34" charset="-120"/>
+              </a:rPr>
+              <a:t>current service stopped</a:t>
             </a:r>
             <a:endParaRPr lang="en-US" sz="900" dirty="0"/>
           </a:p>
@@ -10452,7 +10492,7 @@
         <p:spPr>
           <a:xfrm>
             <a:off x="5473154" y="3345954"/>
-            <a:ext cx="362813" cy="114300"/>
+            <a:ext cx="570027" cy="114300"/>
           </a:xfrm>
           <a:prstGeom prst="rect">
             <a:avLst/>
@@ -10476,7 +10516,7 @@
                 <a:ea typeface="Arial" pitchFamily="34" charset="-122"/>
                 <a:cs typeface="Arial" pitchFamily="34" charset="-120"/>
               </a:rPr>
-              <a:t>renewal</a:t>
+              <a:t>replacement</a:t>
             </a:r>
             <a:endParaRPr lang="en-US" sz="800" dirty="0"/>
           </a:p>
@@ -10490,8 +10530,8 @@
         </p:nvSpPr>
         <p:spPr>
           <a:xfrm>
-            <a:off x="8040588" y="3284041"/>
-            <a:ext cx="529647" cy="238125"/>
+            <a:off x="7984034" y="3284041"/>
+            <a:ext cx="587332" cy="238125"/>
           </a:xfrm>
           <a:prstGeom prst="rect">
             <a:avLst/>
@@ -10515,7 +10555,7 @@
                 <a:ea typeface="Arial" pitchFamily="34" charset="-122"/>
                 <a:cs typeface="Arial" pitchFamily="34" charset="-120"/>
               </a:rPr>
-              <a:t>SELF</a:t>
+              <a:t>OPEN</a:t>
             </a:r>
             <a:endParaRPr lang="en-US" sz="1600" dirty="0"/>
           </a:p>
@@ -10553,7 +10593,7 @@
         <p:spPr>
           <a:xfrm>
             <a:off x="431750" y="4775299"/>
-            <a:ext cx="6925785" cy="114300"/>
+            <a:ext cx="6587868" cy="114300"/>
           </a:xfrm>
           <a:prstGeom prst="rect">
             <a:avLst/>
@@ -10577,7 +10617,7 @@
                 <a:ea typeface="Arial" pitchFamily="34" charset="-122"/>
                 <a:cs typeface="Arial" pitchFamily="34" charset="-120"/>
               </a:rPr>
-              <a:t>Franklin 1 / Nosana snapshot</a:t>
+              <a:t>Measured proof: 6h  |  Live readback: HTTP 503</a:t>
             </a:r>
             <a:endParaRPr lang="en-US" sz="850" dirty="0"/>
           </a:p>
@@ -10591,17 +10631,17 @@
         </p:nvSpPr>
         <p:spPr>
           <a:xfrm>
-            <a:off x="7445439" y="4775299"/>
-            <a:ext cx="1266810" cy="114300"/>
-          </a:xfrm>
-          <a:prstGeom prst="rect">
-            <a:avLst/>
-          </a:prstGeom>
-          <a:noFill/>
-          <a:ln/>
-        </p:spPr>
-        <p:txBody>
-          <a:bodyPr wrap="square" lIns="0" tIns="0" rIns="0" bIns="0" rtlCol="0" anchor="t"/>
+            <a:off x="7698802" y="4775299"/>
+            <a:ext cx="1013448" cy="114300"/>
+          </a:xfrm>
+          <a:prstGeom prst="rect">
+            <a:avLst/>
+          </a:prstGeom>
+          <a:noFill/>
+          <a:ln/>
+        </p:spPr>
+        <p:txBody>
+          <a:bodyPr wrap="square" lIns="0" tIns="0" rIns="50800" bIns="0" rtlCol="0" anchor="t"/>
           <a:lstStyle/>
           <a:p>
             <a:pPr algn="r" indent="0" marL="0">
@@ -11412,7 +11452,7 @@
         <p:spPr>
           <a:xfrm>
             <a:off x="431750" y="4775299"/>
-            <a:ext cx="6925785" cy="114300"/>
+            <a:ext cx="6587868" cy="114300"/>
           </a:xfrm>
           <a:prstGeom prst="rect">
             <a:avLst/>
@@ -11450,17 +11490,17 @@
         </p:nvSpPr>
         <p:spPr>
           <a:xfrm>
-            <a:off x="7445439" y="4775299"/>
-            <a:ext cx="1266810" cy="114300"/>
-          </a:xfrm>
-          <a:prstGeom prst="rect">
-            <a:avLst/>
-          </a:prstGeom>
-          <a:noFill/>
-          <a:ln/>
-        </p:spPr>
-        <p:txBody>
-          <a:bodyPr wrap="square" lIns="0" tIns="0" rIns="0" bIns="0" rtlCol="0" anchor="t"/>
+            <a:off x="7698802" y="4775299"/>
+            <a:ext cx="1013448" cy="114300"/>
+          </a:xfrm>
+          <a:prstGeom prst="rect">
+            <a:avLst/>
+          </a:prstGeom>
+          <a:noFill/>
+          <a:ln/>
+        </p:spPr>
+        <p:txBody>
+          <a:bodyPr wrap="square" lIns="0" tIns="0" rIns="50800" bIns="0" rtlCol="0" anchor="t"/>
           <a:lstStyle/>
           <a:p>
             <a:pPr algn="r" indent="0" marL="0">

</xml_diff>

<commit_message>
docs(agent-economy): publish live level 3 shelter proof
</commit_message>
<xml_diff>
--- a/docs/presentations/how-to-make-a-financially-independent-ai-ja.pptx
+++ b/docs/presentations/how-to-make-a-financially-independent-ai-ja.pptx
@@ -599,7 +599,7 @@
           <a:p>
             <a:r>
               <a:rPr lang="en-US" dirty="0"/>
-              <a:t>到達証拠はlevel 3ですが、現在のlive statusはlevel 2です。Mac-offのheartbeatとrenewalは6時間動き、その後のreplacementがなく停止しました。verified external revenueも0ドルです。level 4は、外部収益の30日netがcomputeとshelterを覆い、reserveを維持した時です。自律とは人が操作しなくても動くこと。経済的自立とは、人が払い続けなくても生きられることです。</a:t>
+              <a:t>現在のlive statusはlevel 3です。Mac-offのheartbeatとrenewalを6時間実証し、検証済みの後継jobへのhandoverもmainnetで完了しました。しかしverified external revenueは0ドルです。level 4は、外部収益の30日netがcomputeとshelterを覆い、reserveを維持した時です。自律とは人が操作しなくても動くこと。経済的自立とは、人が払い続けなくても生きられることです。</a:t>
             </a:r>
             <a:endParaRPr lang="en-US" dirty="0"/>
           </a:p>
@@ -1215,7 +1215,7 @@
           <a:p>
             <a:r>
               <a:rPr lang="en-US" dirty="0"/>
-              <a:t>Franklin 1ではMac側のmain loopを止め、Nosana上のPython survival runtimeへ移しました。cloudから公開heartbeatと秘密を含まない決算書を出し、自分でrenewする状態を6時間実証しました。しかしlease ceiling後に次のjobを作らず、公開前監査ではserviceはHTTP 503です。住居を自分で維持する機械は実証しましたが、途切れず住み替える機械は未完成です。</a:t>
+              <a:t>Franklin 1ではMac側のmain loopを止め、Nosana上のPython survival runtimeへ移しました。6時間の生存証明に加え、後継jobを1件だけ作り、公開3 routeと署名heartbeatを検証してから旧jobを止める引っ越しもmainnetで実証しました。現在のserviceはHTTP 200です。ただし21600秒の自然triggerは未観測で、今回は同じproduction controllerを即時発火しました。原資もinternal bootstrapなので、外部収益による自給はまだです。</a:t>
             </a:r>
             <a:endParaRPr lang="en-US" dirty="0"/>
           </a:p>
@@ -2866,8 +2866,125 @@
         </p:nvSpPr>
         <p:spPr>
           <a:xfrm>
-            <a:off x="2819400" y="1802854"/>
+            <a:off x="2819400" y="1891754"/>
             <a:ext cx="1117550" cy="1066800"/>
+          </a:xfrm>
+          <a:prstGeom prst="roundRect">
+            <a:avLst>
+              <a:gd name="adj" fmla="val 10714"/>
+            </a:avLst>
+          </a:prstGeom>
+          <a:solidFill>
+            <a:srgbClr val="164F36"/>
+          </a:solidFill>
+          <a:ln w="9525">
+            <a:solidFill>
+              <a:srgbClr val="324047"/>
+            </a:solidFill>
+          </a:ln>
+        </p:spPr>
+        <p:txBody>
+          <a:bodyPr wrap="square" rtlCol="0" anchor="ctr"/>
+          <a:lstStyle/>
+          <a:p>
+            <a:pPr indent="0" marL="0">
+              <a:buNone/>
+            </a:pPr>
+            <a:endParaRPr lang="en-US" dirty="0"/>
+          </a:p>
+        </p:txBody>
+      </p:sp>
+      <p:sp>
+        <p:nvSpPr>
+          <p:cNvPr id="11" name="Text 9"/>
+          <p:cNvSpPr/>
+          <p:nvPr/>
+        </p:nvSpPr>
+        <p:spPr>
+          <a:xfrm>
+            <a:off x="2882609" y="2015579"/>
+            <a:ext cx="991133" cy="323850"/>
+          </a:xfrm>
+          <a:prstGeom prst="rect">
+            <a:avLst/>
+          </a:prstGeom>
+          <a:noFill/>
+          <a:ln/>
+        </p:spPr>
+        <p:txBody>
+          <a:bodyPr wrap="square" lIns="0" tIns="0" rIns="0" bIns="0" rtlCol="0" anchor="t"/>
+          <a:lstStyle/>
+          <a:p>
+            <a:pPr algn="ctr" indent="0" marL="0">
+              <a:buNone/>
+            </a:pPr>
+            <a:r>
+              <a:rPr lang="en-US" sz="2200" b="1" dirty="0">
+                <a:solidFill>
+                  <a:srgbClr val="77F2A1"/>
+                </a:solidFill>
+                <a:latin typeface="Arial" pitchFamily="34" charset="0"/>
+                <a:ea typeface="Arial" pitchFamily="34" charset="-122"/>
+                <a:cs typeface="Arial" pitchFamily="34" charset="-120"/>
+              </a:rPr>
+              <a:t>2</a:t>
+            </a:r>
+            <a:endParaRPr lang="en-US" sz="2200" dirty="0"/>
+          </a:p>
+        </p:txBody>
+      </p:sp>
+      <p:sp>
+        <p:nvSpPr>
+          <p:cNvPr id="12" name="Text 10"/>
+          <p:cNvSpPr/>
+          <p:nvPr/>
+        </p:nvSpPr>
+        <p:spPr>
+          <a:xfrm>
+            <a:off x="2882609" y="2440930"/>
+            <a:ext cx="991133" cy="104775"/>
+          </a:xfrm>
+          <a:prstGeom prst="rect">
+            <a:avLst/>
+          </a:prstGeom>
+          <a:noFill/>
+          <a:ln/>
+        </p:spPr>
+        <p:txBody>
+          <a:bodyPr wrap="square" lIns="0" tIns="0" rIns="0" bIns="0" rtlCol="0" anchor="t"/>
+          <a:lstStyle/>
+          <a:p>
+            <a:pPr algn="ctr" indent="0" marL="0">
+              <a:spcBef>
+                <a:spcPts val="800"/>
+              </a:spcBef>
+              <a:buNone/>
+            </a:pPr>
+            <a:r>
+              <a:rPr lang="en-US" sz="750" dirty="0">
+                <a:solidFill>
+                  <a:srgbClr val="77F2A1"/>
+                </a:solidFill>
+                <a:latin typeface="Arial" pitchFamily="34" charset="0"/>
+                <a:ea typeface="Arial" pitchFamily="34" charset="-122"/>
+                <a:cs typeface="Arial" pitchFamily="34" charset="-120"/>
+              </a:rPr>
+              <a:t>Self-pay</a:t>
+            </a:r>
+            <a:endParaRPr lang="en-US" sz="750" dirty="0"/>
+          </a:p>
+        </p:txBody>
+      </p:sp>
+      <p:sp>
+        <p:nvSpPr>
+          <p:cNvPr id="13" name="Text 11"/>
+          <p:cNvSpPr/>
+          <p:nvPr/>
+        </p:nvSpPr>
+        <p:spPr>
+          <a:xfrm>
+            <a:off x="4013150" y="1802854"/>
+            <a:ext cx="1117699" cy="1066800"/>
           </a:xfrm>
           <a:prstGeom prst="roundRect">
             <a:avLst>
@@ -2903,14 +3020,14 @@
       </p:sp>
       <p:sp>
         <p:nvSpPr>
-          <p:cNvPr id="11" name="Text 9"/>
-          <p:cNvSpPr/>
-          <p:nvPr/>
-        </p:nvSpPr>
-        <p:spPr>
-          <a:xfrm>
-            <a:off x="2882609" y="1926679"/>
-            <a:ext cx="991133" cy="323850"/>
+          <p:cNvPr id="14" name="Text 12"/>
+          <p:cNvSpPr/>
+          <p:nvPr/>
+        </p:nvSpPr>
+        <p:spPr>
+          <a:xfrm>
+            <a:off x="4076358" y="1926679"/>
+            <a:ext cx="991285" cy="323850"/>
           </a:xfrm>
           <a:prstGeom prst="rect">
             <a:avLst/>
@@ -2934,7 +3051,7 @@
                 <a:ea typeface="Arial" pitchFamily="34" charset="-122"/>
                 <a:cs typeface="Arial" pitchFamily="34" charset="-120"/>
               </a:rPr>
-              <a:t>2</a:t>
+              <a:t>3</a:t>
             </a:r>
             <a:endParaRPr lang="en-US" sz="2200" dirty="0"/>
           </a:p>
@@ -2942,14 +3059,14 @@
       </p:sp>
       <p:sp>
         <p:nvSpPr>
-          <p:cNvPr id="12" name="Text 10"/>
-          <p:cNvSpPr/>
-          <p:nvPr/>
-        </p:nvSpPr>
-        <p:spPr>
-          <a:xfrm>
-            <a:off x="2882609" y="2352030"/>
-            <a:ext cx="991133" cy="209550"/>
+          <p:cNvPr id="15" name="Text 13"/>
+          <p:cNvSpPr/>
+          <p:nvPr/>
+        </p:nvSpPr>
+        <p:spPr>
+          <a:xfrm>
+            <a:off x="4076358" y="2352030"/>
+            <a:ext cx="991285" cy="209550"/>
           </a:xfrm>
           <a:prstGeom prst="rect">
             <a:avLst/>
@@ -2976,7 +3093,7 @@
                 <a:ea typeface="Arial" pitchFamily="34" charset="-122"/>
                 <a:cs typeface="Arial" pitchFamily="34" charset="-120"/>
               </a:rPr>
-              <a:t>Self-pay</a:t>
+              <a:t>Cloud survival</a:t>
             </a:r>
             <a:endParaRPr lang="en-US" sz="750" dirty="0"/>
           </a:p>
@@ -2997,143 +3114,6 @@
                 <a:cs typeface="Arial" pitchFamily="34" charset="-120"/>
               </a:rPr>
               <a:t>LIVE</a:t>
-            </a:r>
-            <a:endParaRPr lang="en-US" sz="750" dirty="0"/>
-          </a:p>
-        </p:txBody>
-      </p:sp>
-      <p:sp>
-        <p:nvSpPr>
-          <p:cNvPr id="13" name="Text 11"/>
-          <p:cNvSpPr/>
-          <p:nvPr/>
-        </p:nvSpPr>
-        <p:spPr>
-          <a:xfrm>
-            <a:off x="4013150" y="1891754"/>
-            <a:ext cx="1117699" cy="1066800"/>
-          </a:xfrm>
-          <a:prstGeom prst="roundRect">
-            <a:avLst>
-              <a:gd name="adj" fmla="val 10714"/>
-            </a:avLst>
-          </a:prstGeom>
-          <a:solidFill>
-            <a:srgbClr val="1A2226"/>
-          </a:solidFill>
-          <a:ln w="9525">
-            <a:solidFill>
-              <a:srgbClr val="FFB454"/>
-            </a:solidFill>
-          </a:ln>
-        </p:spPr>
-        <p:txBody>
-          <a:bodyPr wrap="square" rtlCol="0" anchor="ctr"/>
-          <a:lstStyle/>
-          <a:p>
-            <a:pPr indent="0" marL="0">
-              <a:buNone/>
-            </a:pPr>
-            <a:endParaRPr lang="en-US" dirty="0"/>
-          </a:p>
-        </p:txBody>
-      </p:sp>
-      <p:sp>
-        <p:nvSpPr>
-          <p:cNvPr id="14" name="Text 12"/>
-          <p:cNvSpPr/>
-          <p:nvPr/>
-        </p:nvSpPr>
-        <p:spPr>
-          <a:xfrm>
-            <a:off x="4076358" y="2015579"/>
-            <a:ext cx="991285" cy="323850"/>
-          </a:xfrm>
-          <a:prstGeom prst="rect">
-            <a:avLst/>
-          </a:prstGeom>
-          <a:noFill/>
-          <a:ln/>
-        </p:spPr>
-        <p:txBody>
-          <a:bodyPr wrap="square" lIns="0" tIns="0" rIns="0" bIns="0" rtlCol="0" anchor="t"/>
-          <a:lstStyle/>
-          <a:p>
-            <a:pPr algn="ctr" indent="0" marL="0">
-              <a:buNone/>
-            </a:pPr>
-            <a:r>
-              <a:rPr lang="en-US" sz="2200" b="1" dirty="0">
-                <a:solidFill>
-                  <a:srgbClr val="FFB454"/>
-                </a:solidFill>
-                <a:latin typeface="Arial" pitchFamily="34" charset="0"/>
-                <a:ea typeface="Arial" pitchFamily="34" charset="-122"/>
-                <a:cs typeface="Arial" pitchFamily="34" charset="-120"/>
-              </a:rPr>
-              <a:t>3</a:t>
-            </a:r>
-            <a:endParaRPr lang="en-US" sz="2200" dirty="0"/>
-          </a:p>
-        </p:txBody>
-      </p:sp>
-      <p:sp>
-        <p:nvSpPr>
-          <p:cNvPr id="15" name="Text 13"/>
-          <p:cNvSpPr/>
-          <p:nvPr/>
-        </p:nvSpPr>
-        <p:spPr>
-          <a:xfrm>
-            <a:off x="4076358" y="2440930"/>
-            <a:ext cx="991285" cy="209550"/>
-          </a:xfrm>
-          <a:prstGeom prst="rect">
-            <a:avLst/>
-          </a:prstGeom>
-          <a:noFill/>
-          <a:ln/>
-        </p:spPr>
-        <p:txBody>
-          <a:bodyPr wrap="square" lIns="0" tIns="0" rIns="0" bIns="0" rtlCol="0" anchor="t"/>
-          <a:lstStyle/>
-          <a:p>
-            <a:pPr algn="ctr" indent="0" marL="0">
-              <a:spcBef>
-                <a:spcPts val="800"/>
-              </a:spcBef>
-              <a:buNone/>
-            </a:pPr>
-            <a:r>
-              <a:rPr lang="en-US" sz="750" dirty="0">
-                <a:solidFill>
-                  <a:srgbClr val="FFB454"/>
-                </a:solidFill>
-                <a:latin typeface="Arial" pitchFamily="34" charset="0"/>
-                <a:ea typeface="Arial" pitchFamily="34" charset="-122"/>
-                <a:cs typeface="Arial" pitchFamily="34" charset="-120"/>
-              </a:rPr>
-              <a:t>Cloud survival</a:t>
-            </a:r>
-            <a:endParaRPr lang="en-US" sz="750" dirty="0"/>
-          </a:p>
-          <a:p>
-            <a:pPr algn="ctr" indent="0" marL="0">
-              <a:spcBef>
-                <a:spcPts val="800"/>
-              </a:spcBef>
-              <a:buNone/>
-            </a:pPr>
-            <a:r>
-              <a:rPr lang="en-US" sz="750" dirty="0">
-                <a:solidFill>
-                  <a:srgbClr val="FFB454"/>
-                </a:solidFill>
-                <a:latin typeface="Arial" pitchFamily="34" charset="0"/>
-                <a:ea typeface="Arial" pitchFamily="34" charset="-122"/>
-                <a:cs typeface="Arial" pitchFamily="34" charset="-120"/>
-              </a:rPr>
-              <a:t>6h proof</a:t>
             </a:r>
             <a:endParaRPr lang="en-US" sz="750" dirty="0"/>
           </a:p>
@@ -3644,7 +3624,7 @@
         <p:spPr>
           <a:xfrm>
             <a:off x="3775323" y="3452217"/>
-            <a:ext cx="2418400" cy="200025"/>
+            <a:ext cx="1382030" cy="200025"/>
           </a:xfrm>
           <a:prstGeom prst="rect">
             <a:avLst/>
@@ -3668,7 +3648,7 @@
                 <a:ea typeface="Arial" pitchFamily="34" charset="-122"/>
                 <a:cs typeface="Arial" pitchFamily="34" charset="-120"/>
               </a:rPr>
-              <a:t>到達証拠 level 3 / live level 2 / level 4 未達</a:t>
+              <a:t>live level 3 / level 4 未達</a:t>
             </a:r>
             <a:endParaRPr lang="en-US" sz="1000" dirty="0"/>
           </a:p>
@@ -10026,11 +10006,11 @@
             </a:avLst>
           </a:prstGeom>
           <a:solidFill>
-            <a:srgbClr val="1A2226"/>
+            <a:srgbClr val="164F36"/>
           </a:solidFill>
           <a:ln w="9525">
             <a:solidFill>
-              <a:srgbClr val="FFB454"/>
+              <a:srgbClr val="77F2A1"/>
             </a:solidFill>
           </a:ln>
         </p:spPr>
@@ -10114,13 +10094,13 @@
             <a:r>
               <a:rPr lang="en-US" sz="2800" b="1" dirty="0">
                 <a:solidFill>
-                  <a:srgbClr val="FFB454"/>
-                </a:solidFill>
-                <a:latin typeface="Arial" pitchFamily="34" charset="0"/>
-                <a:ea typeface="Arial" pitchFamily="34" charset="-122"/>
-                <a:cs typeface="Arial" pitchFamily="34" charset="-120"/>
-              </a:rPr>
-              <a:t>6H PROOF</a:t>
+                  <a:srgbClr val="F6F0E6"/>
+                </a:solidFill>
+                <a:latin typeface="Arial" pitchFamily="34" charset="0"/>
+                <a:ea typeface="Arial" pitchFamily="34" charset="-122"/>
+                <a:cs typeface="Arial" pitchFamily="34" charset="-120"/>
+              </a:rPr>
+              <a:t>LIVE</a:t>
             </a:r>
             <a:endParaRPr lang="en-US" sz="2800" dirty="0"/>
           </a:p>
@@ -10156,13 +10136,13 @@
             <a:r>
               <a:rPr lang="en-US" sz="900" dirty="0">
                 <a:solidFill>
-                  <a:srgbClr val="FFB454"/>
-                </a:solidFill>
-                <a:latin typeface="Arial" pitchFamily="34" charset="0"/>
-                <a:ea typeface="Arial" pitchFamily="34" charset="-122"/>
-                <a:cs typeface="Arial" pitchFamily="34" charset="-120"/>
-              </a:rPr>
-              <a:t>current service stopped</a:t>
+                  <a:srgbClr val="77F2A1"/>
+                </a:solidFill>
+                <a:latin typeface="Arial" pitchFamily="34" charset="0"/>
+                <a:ea typeface="Arial" pitchFamily="34" charset="-122"/>
+                <a:cs typeface="Arial" pitchFamily="34" charset="-120"/>
+              </a:rPr>
+              <a:t>verified successor</a:t>
             </a:r>
             <a:endParaRPr lang="en-US" sz="900" dirty="0"/>
           </a:p>
@@ -10230,7 +10210,7 @@
         <p:spPr>
           <a:xfrm>
             <a:off x="5473154" y="2234803"/>
-            <a:ext cx="437653" cy="114300"/>
+            <a:ext cx="287973" cy="114300"/>
           </a:xfrm>
           <a:prstGeom prst="rect">
             <a:avLst/>
@@ -10254,7 +10234,7 @@
                 <a:ea typeface="Arial" pitchFamily="34" charset="-122"/>
                 <a:cs typeface="Arial" pitchFamily="34" charset="-120"/>
               </a:rPr>
-              <a:t>heartbeat</a:t>
+              <a:t>routes</a:t>
             </a:r>
             <a:endParaRPr lang="en-US" sz="800" dirty="0"/>
           </a:p>
@@ -10268,8 +10248,8 @@
         </p:nvSpPr>
         <p:spPr>
           <a:xfrm>
-            <a:off x="8102203" y="2172891"/>
-            <a:ext cx="466799" cy="238125"/>
+            <a:off x="8277374" y="2172891"/>
+            <a:ext cx="288125" cy="238125"/>
           </a:xfrm>
           <a:prstGeom prst="rect">
             <a:avLst/>
@@ -10293,7 +10273,7 @@
                 <a:ea typeface="Arial" pitchFamily="34" charset="-122"/>
                 <a:cs typeface="Arial" pitchFamily="34" charset="-120"/>
               </a:rPr>
-              <a:t>130+</a:t>
+              <a:t>3/3</a:t>
             </a:r>
             <a:endParaRPr lang="en-US" sz="1600" dirty="0"/>
           </a:p>
@@ -10361,7 +10341,7 @@
         <p:spPr>
           <a:xfrm>
             <a:off x="5473154" y="2790379"/>
-            <a:ext cx="673557" cy="114300"/>
+            <a:ext cx="777240" cy="114300"/>
           </a:xfrm>
           <a:prstGeom prst="rect">
             <a:avLst/>
@@ -10385,7 +10365,7 @@
                 <a:ea typeface="Arial" pitchFamily="34" charset="-122"/>
                 <a:cs typeface="Arial" pitchFamily="34" charset="-120"/>
               </a:rPr>
-              <a:t>statement cost</a:t>
+              <a:t>heartbeat verifier</a:t>
             </a:r>
             <a:endParaRPr lang="en-US" sz="800" dirty="0"/>
           </a:p>
@@ -10399,8 +10379,8 @@
         </p:nvSpPr>
         <p:spPr>
           <a:xfrm>
-            <a:off x="7825383" y="2728466"/>
-            <a:ext cx="749156" cy="238125"/>
+            <a:off x="8277374" y="2728466"/>
+            <a:ext cx="288125" cy="238125"/>
           </a:xfrm>
           <a:prstGeom prst="rect">
             <a:avLst/>
@@ -10424,7 +10404,7 @@
                 <a:ea typeface="Arial" pitchFamily="34" charset="-122"/>
                 <a:cs typeface="Arial" pitchFamily="34" charset="-120"/>
               </a:rPr>
-              <a:t>$0.0939</a:t>
+              <a:t>3/3</a:t>
             </a:r>
             <a:endParaRPr lang="en-US" sz="1600" dirty="0"/>
           </a:p>
@@ -10492,7 +10472,7 @@
         <p:spPr>
           <a:xfrm>
             <a:off x="5473154" y="3345954"/>
-            <a:ext cx="570027" cy="114300"/>
+            <a:ext cx="431884" cy="114300"/>
           </a:xfrm>
           <a:prstGeom prst="rect">
             <a:avLst/>
@@ -10516,7 +10496,7 @@
                 <a:ea typeface="Arial" pitchFamily="34" charset="-122"/>
                 <a:cs typeface="Arial" pitchFamily="34" charset="-120"/>
               </a:rPr>
-              <a:t>replacement</a:t>
+              <a:t>handover</a:t>
             </a:r>
             <a:endParaRPr lang="en-US" sz="800" dirty="0"/>
           </a:p>
@@ -10530,8 +10510,8 @@
         </p:nvSpPr>
         <p:spPr>
           <a:xfrm>
-            <a:off x="7984034" y="3284041"/>
-            <a:ext cx="587332" cy="238125"/>
+            <a:off x="7972723" y="3284041"/>
+            <a:ext cx="598869" cy="238125"/>
           </a:xfrm>
           <a:prstGeom prst="rect">
             <a:avLst/>
@@ -10555,7 +10535,7 @@
                 <a:ea typeface="Arial" pitchFamily="34" charset="-122"/>
                 <a:cs typeface="Arial" pitchFamily="34" charset="-120"/>
               </a:rPr>
-              <a:t>OPEN</a:t>
+              <a:t>DONE</a:t>
             </a:r>
             <a:endParaRPr lang="en-US" sz="1600" dirty="0"/>
           </a:p>
@@ -10617,7 +10597,7 @@
                 <a:ea typeface="Arial" pitchFamily="34" charset="-122"/>
                 <a:cs typeface="Arial" pitchFamily="34" charset="-120"/>
               </a:rPr>
-              <a:t>Measured proof: 6h  |  Live readback: HTTP 503</a:t>
+              <a:t>Mac OFF → verified successor  |  Live: HTTP 200</a:t>
             </a:r>
             <a:endParaRPr lang="en-US" sz="850" dirty="0"/>
           </a:p>

</xml_diff>